<commit_message>
update homepage info and config
</commit_message>
<xml_diff>
--- a/unity.pptx
+++ b/unity.pptx
@@ -104,6 +104,11 @@
       </a:defRPr>
     </a:lvl9pPr>
   </p:defaultTextStyle>
+  <p:extLst>
+    <p:ext uri="{EFAFB233-063F-42B5-8137-9DF3F51BA10A}">
+      <p15:sldGuideLst xmlns:p15="http://schemas.microsoft.com/office/powerpoint/2012/main"/>
+    </p:ext>
+  </p:extLst>
 </p:presentation>
 </file>
 
@@ -3344,7 +3349,7 @@
         </p:blipFill>
         <p:spPr>
           <a:xfrm>
-            <a:off x="6051083" y="1502939"/>
+            <a:off x="6620047" y="1670719"/>
             <a:ext cx="1685109" cy="904240"/>
           </a:xfrm>
           <a:prstGeom prst="roundRect">
@@ -3375,7 +3380,7 @@
         </p:blipFill>
         <p:spPr>
           <a:xfrm>
-            <a:off x="6006167" y="3875314"/>
+            <a:off x="6575131" y="3453108"/>
             <a:ext cx="1730025" cy="1016388"/>
           </a:xfrm>
           <a:prstGeom prst="roundRect">
@@ -3406,7 +3411,7 @@
         </p:blipFill>
         <p:spPr>
           <a:xfrm>
-            <a:off x="3958046" y="1502939"/>
+            <a:off x="3391789" y="1670719"/>
             <a:ext cx="1654486" cy="882433"/>
           </a:xfrm>
           <a:prstGeom prst="roundRect">
@@ -3437,7 +3442,7 @@
         </p:blipFill>
         <p:spPr>
           <a:xfrm>
-            <a:off x="3958046" y="3837965"/>
+            <a:off x="3391789" y="3415759"/>
             <a:ext cx="1730025" cy="1053737"/>
           </a:xfrm>
           <a:prstGeom prst="roundRect">

</xml_diff>